<commit_message>
feat(v5.0.59): PPT-SUPER 新增 11 个洞察模板(tpl-109~119) + bullets max_lines 截断 + 推广页录屏改 mp4
- ppt-fill.js: bullets 角色支持 slot.max_lines 截断, 防多行溢出
- templates.json: chars 上限重标 + 注册 tpl-108~119
- 新模板 tpl-109~119 素材(template/thumb/blank), 对齐惯例只入库 3 文件
- docs 推广页 6 处录屏 gif->mp4(video 标签)
- 版本号 4 处 bump 5.0.58 -> 5.0.59
- .gitignore 排除 artifacts/ 构建工作区与 *.bak

Co-Authored-By: Claude Opus 4.8 (1M context) <noreply@anthropic.com>
</commit_message>
<xml_diff>
--- a/src/ppt-super/assets/tpl-01-quad-grid/template.pptx
+++ b/src/ppt-super/assets/tpl-01-quad-grid/template.pptx
@@ -3136,7 +3136,14 @@
           <a:bodyPr rtlCol="0" anchor="ctr"/>
           <a:lstStyle/>
           <a:p>
-            <a:pPr algn="ctr"/>
+            <a:pPr algn="ctr">
+              <a:spcBef>
+                <a:spcPts val="0"/>
+              </a:spcBef>
+              <a:spcAft>
+                <a:spcPts val="0"/>
+              </a:spcAft>
+            </a:pPr>
           </a:p>
         </p:txBody>
       </p:sp>
@@ -3166,14 +3173,21 @@
               <a:lnSpc>
                 <a:spcPct val="112000"/>
               </a:lnSpc>
+              <a:spcBef>
+                <a:spcPts val="0"/>
+              </a:spcBef>
+              <a:spcAft>
+                <a:spcPts val="0"/>
+              </a:spcAft>
             </a:pPr>
             <a:r>
-              <a:rPr sz="1400" b="1" i="0">
+              <a:rPr sz="1400" b="1" i="0" lang="zh-CN" altLang="zh-CN">
                 <a:solidFill>
                   <a:srgbClr val="FFFFFF"/>
                 </a:solidFill>
                 <a:latin typeface="Microsoft YaHei"/>
                 <a:ea typeface="Microsoft YaHei"/>
+                <a:cs typeface="Microsoft YaHei"/>
               </a:rPr>
               <a:t>昇腾算力</a:t>
             </a:r>
@@ -3206,14 +3220,21 @@
               <a:lnSpc>
                 <a:spcPct val="112000"/>
               </a:lnSpc>
+              <a:spcBef>
+                <a:spcPts val="0"/>
+              </a:spcBef>
+              <a:spcAft>
+                <a:spcPts val="0"/>
+              </a:spcAft>
             </a:pPr>
             <a:r>
-              <a:rPr sz="2200" b="1" i="0">
+              <a:rPr sz="2200" b="1" i="0" lang="zh-CN" altLang="zh-CN">
                 <a:solidFill>
                   <a:srgbClr val="B90A0A"/>
                 </a:solidFill>
                 <a:latin typeface="Microsoft YaHei"/>
                 <a:ea typeface="Microsoft YaHei"/>
+                <a:cs typeface="Microsoft YaHei"/>
               </a:rPr>
               <a:t>昇腾超节点集群四大能力就绪，万卡训练效率提升 3 倍</a:t>
             </a:r>
@@ -3300,7 +3321,14 @@
           <a:bodyPr rtlCol="0" anchor="ctr"/>
           <a:lstStyle/>
           <a:p>
-            <a:pPr algn="ctr"/>
+            <a:pPr algn="ctr">
+              <a:spcBef>
+                <a:spcPts val="0"/>
+              </a:spcBef>
+              <a:spcAft>
+                <a:spcPts val="0"/>
+              </a:spcAft>
+            </a:pPr>
           </a:p>
         </p:txBody>
       </p:sp>
@@ -3344,7 +3372,14 @@
           <a:bodyPr rtlCol="0" anchor="ctr"/>
           <a:lstStyle/>
           <a:p>
-            <a:pPr algn="ctr"/>
+            <a:pPr algn="ctr">
+              <a:spcBef>
+                <a:spcPts val="0"/>
+              </a:spcBef>
+              <a:spcAft>
+                <a:spcPts val="0"/>
+              </a:spcAft>
+            </a:pPr>
           </a:p>
         </p:txBody>
       </p:sp>
@@ -3388,7 +3423,14 @@
           <a:bodyPr rtlCol="0" anchor="ctr"/>
           <a:lstStyle/>
           <a:p>
-            <a:pPr algn="ctr"/>
+            <a:pPr algn="ctr">
+              <a:spcBef>
+                <a:spcPts val="0"/>
+              </a:spcBef>
+              <a:spcAft>
+                <a:spcPts val="0"/>
+              </a:spcAft>
+            </a:pPr>
           </a:p>
         </p:txBody>
       </p:sp>
@@ -3418,14 +3460,21 @@
               <a:lnSpc>
                 <a:spcPct val="112000"/>
               </a:lnSpc>
+              <a:spcBef>
+                <a:spcPts val="0"/>
+              </a:spcBef>
+              <a:spcAft>
+                <a:spcPts val="0"/>
+              </a:spcAft>
             </a:pPr>
             <a:r>
-              <a:rPr sz="1500" b="1" i="0">
+              <a:rPr sz="1500" b="1" i="0" lang="zh-CN" altLang="zh-CN">
                 <a:solidFill>
                   <a:srgbClr val="262626"/>
                 </a:solidFill>
                 <a:latin typeface="Microsoft YaHei"/>
                 <a:ea typeface="Microsoft YaHei"/>
+                <a:cs typeface="Microsoft YaHei"/>
               </a:rPr>
               <a:t>算力底座: 超节点架构突破单点算力上限</a:t>
             </a:r>
@@ -3458,14 +3507,21 @@
               <a:lnSpc>
                 <a:spcPct val="130000"/>
               </a:lnSpc>
+              <a:spcBef>
+                <a:spcPts val="0"/>
+              </a:spcBef>
+              <a:spcAft>
+                <a:spcPts val="0"/>
+              </a:spcAft>
             </a:pPr>
             <a:r>
-              <a:rPr sz="1150" b="0" i="0">
+              <a:rPr sz="1150" b="0" i="0" lang="zh-CN" altLang="zh-CN">
                 <a:solidFill>
                   <a:srgbClr val="262626"/>
                 </a:solidFill>
                 <a:latin typeface="Microsoft YaHei"/>
                 <a:ea typeface="Microsoft YaHei"/>
+                <a:cs typeface="Microsoft YaHei"/>
               </a:rPr>
               <a:t>超节点架构通过 384 卡全互联设计突破单点算力上限, 跨柜通信时延降至传统方案的 1/5, 单集群算力达 16 EFLOPS, 可支撑万亿参数大模型完整预训练。在此基础上, 存算分离与高速缓存层将 Checkpoint 写入耗时从 15 分钟压缩至 90 秒, 异构资源池化统一调度使训推一体资源利用率从 58% 提升至 81%; 内存语义互联进一步池化显存, 支撑超长序列训练突破单卡容量限制。同时液冷整机柜交付将 PUE 降至 1.12, 单位算力能耗下降 27%, 为大规模训练提供坚实且经济的算力底座。</a:t>
             </a:r>
@@ -3514,7 +3570,14 @@
           <a:bodyPr rtlCol="0" anchor="ctr"/>
           <a:lstStyle/>
           <a:p>
-            <a:pPr algn="ctr"/>
+            <a:pPr algn="ctr">
+              <a:spcBef>
+                <a:spcPts val="0"/>
+              </a:spcBef>
+              <a:spcAft>
+                <a:spcPts val="0"/>
+              </a:spcAft>
+            </a:pPr>
           </a:p>
         </p:txBody>
       </p:sp>
@@ -3560,7 +3623,14 @@
           <a:bodyPr rtlCol="0" anchor="ctr"/>
           <a:lstStyle/>
           <a:p>
-            <a:pPr algn="ctr"/>
+            <a:pPr algn="ctr">
+              <a:spcBef>
+                <a:spcPts val="0"/>
+              </a:spcBef>
+              <a:spcAft>
+                <a:spcPts val="0"/>
+              </a:spcAft>
+            </a:pPr>
           </a:p>
         </p:txBody>
       </p:sp>
@@ -4022,14 +4092,21 @@
               <a:lnSpc>
                 <a:spcPct val="112000"/>
               </a:lnSpc>
+              <a:spcBef>
+                <a:spcPts val="0"/>
+              </a:spcBef>
+              <a:spcAft>
+                <a:spcPts val="0"/>
+              </a:spcAft>
             </a:pPr>
             <a:r>
-              <a:rPr sz="950" b="0" i="0">
+              <a:rPr sz="950" b="0" i="0" lang="zh-CN" altLang="zh-CN">
                 <a:solidFill>
                   <a:srgbClr val="595959"/>
                 </a:solidFill>
                 <a:latin typeface="Microsoft YaHei"/>
                 <a:ea typeface="Microsoft YaHei"/>
+                <a:cs typeface="Microsoft YaHei"/>
               </a:rPr>
               <a:t>Ascend SuperPod</a:t>
             </a:r>
@@ -4076,7 +4153,14 @@
           <a:bodyPr rtlCol="0" anchor="ctr"/>
           <a:lstStyle/>
           <a:p>
-            <a:pPr algn="ctr"/>
+            <a:pPr algn="ctr">
+              <a:spcBef>
+                <a:spcPts val="0"/>
+              </a:spcBef>
+              <a:spcAft>
+                <a:spcPts val="0"/>
+              </a:spcAft>
+            </a:pPr>
           </a:p>
         </p:txBody>
       </p:sp>
@@ -4106,14 +4190,21 @@
               <a:lnSpc>
                 <a:spcPct val="112000"/>
               </a:lnSpc>
+              <a:spcBef>
+                <a:spcPts val="0"/>
+              </a:spcBef>
+              <a:spcAft>
+                <a:spcPts val="0"/>
+              </a:spcAft>
             </a:pPr>
             <a:r>
-              <a:rPr sz="1300" b="1" i="0">
+              <a:rPr sz="1300" b="1" i="0" lang="zh-CN" altLang="zh-CN">
                 <a:solidFill>
                   <a:srgbClr val="262626"/>
                 </a:solidFill>
                 <a:latin typeface="Microsoft YaHei"/>
                 <a:ea typeface="Microsoft YaHei"/>
+                <a:cs typeface="Microsoft YaHei"/>
               </a:rPr>
               <a:t>16 EFLOPS</a:t>
             </a:r>
@@ -4160,7 +4251,14 @@
           <a:bodyPr rtlCol="0" anchor="ctr"/>
           <a:lstStyle/>
           <a:p>
-            <a:pPr algn="ctr"/>
+            <a:pPr algn="ctr">
+              <a:spcBef>
+                <a:spcPts val="0"/>
+              </a:spcBef>
+              <a:spcAft>
+                <a:spcPts val="0"/>
+              </a:spcAft>
+            </a:pPr>
           </a:p>
         </p:txBody>
       </p:sp>
@@ -4190,14 +4288,21 @@
               <a:lnSpc>
                 <a:spcPct val="112000"/>
               </a:lnSpc>
+              <a:spcBef>
+                <a:spcPts val="0"/>
+              </a:spcBef>
+              <a:spcAft>
+                <a:spcPts val="0"/>
+              </a:spcAft>
             </a:pPr>
             <a:r>
-              <a:rPr sz="1300" b="1" i="0">
+              <a:rPr sz="1300" b="1" i="0" lang="zh-CN" altLang="zh-CN">
                 <a:solidFill>
                   <a:srgbClr val="262626"/>
                 </a:solidFill>
                 <a:latin typeface="Microsoft YaHei"/>
                 <a:ea typeface="Microsoft YaHei"/>
+                <a:cs typeface="Microsoft YaHei"/>
               </a:rPr>
               <a:t>利用率 58%→81%</a:t>
             </a:r>
@@ -4246,7 +4351,14 @@
           <a:bodyPr rtlCol="0" anchor="ctr"/>
           <a:lstStyle/>
           <a:p>
-            <a:pPr algn="ctr"/>
+            <a:pPr algn="ctr">
+              <a:spcBef>
+                <a:spcPts val="0"/>
+              </a:spcBef>
+              <a:spcAft>
+                <a:spcPts val="0"/>
+              </a:spcAft>
+            </a:pPr>
           </a:p>
         </p:txBody>
       </p:sp>
@@ -4290,7 +4402,14 @@
           <a:bodyPr rtlCol="0" anchor="ctr"/>
           <a:lstStyle/>
           <a:p>
-            <a:pPr algn="ctr"/>
+            <a:pPr algn="ctr">
+              <a:spcBef>
+                <a:spcPts val="0"/>
+              </a:spcBef>
+              <a:spcAft>
+                <a:spcPts val="0"/>
+              </a:spcAft>
+            </a:pPr>
           </a:p>
         </p:txBody>
       </p:sp>
@@ -4334,7 +4453,14 @@
           <a:bodyPr rtlCol="0" anchor="ctr"/>
           <a:lstStyle/>
           <a:p>
-            <a:pPr algn="ctr"/>
+            <a:pPr algn="ctr">
+              <a:spcBef>
+                <a:spcPts val="0"/>
+              </a:spcBef>
+              <a:spcAft>
+                <a:spcPts val="0"/>
+              </a:spcAft>
+            </a:pPr>
           </a:p>
         </p:txBody>
       </p:sp>
@@ -4364,14 +4490,21 @@
               <a:lnSpc>
                 <a:spcPct val="112000"/>
               </a:lnSpc>
+              <a:spcBef>
+                <a:spcPts val="0"/>
+              </a:spcBef>
+              <a:spcAft>
+                <a:spcPts val="0"/>
+              </a:spcAft>
             </a:pPr>
             <a:r>
-              <a:rPr sz="1500" b="1" i="0">
+              <a:rPr sz="1500" b="1" i="0" lang="zh-CN" altLang="zh-CN">
                 <a:solidFill>
                   <a:srgbClr val="262626"/>
                 </a:solidFill>
                 <a:latin typeface="Microsoft YaHei"/>
                 <a:ea typeface="Microsoft YaHei"/>
+                <a:cs typeface="Microsoft YaHei"/>
               </a:rPr>
               <a:t>训练效率: 并行策略自动寻优, 线性度 92%</a:t>
             </a:r>
@@ -4404,14 +4537,21 @@
               <a:lnSpc>
                 <a:spcPct val="130000"/>
               </a:lnSpc>
+              <a:spcBef>
+                <a:spcPts val="0"/>
+              </a:spcBef>
+              <a:spcAft>
+                <a:spcPts val="0"/>
+              </a:spcAft>
             </a:pPr>
             <a:r>
-              <a:rPr sz="1150" b="0" i="0">
+              <a:rPr sz="1150" b="0" i="0" lang="zh-CN" altLang="zh-CN">
                 <a:solidFill>
                   <a:srgbClr val="262626"/>
                 </a:solidFill>
                 <a:latin typeface="Microsoft YaHei"/>
                 <a:ea typeface="Microsoft YaHei"/>
+                <a:cs typeface="Microsoft YaHei"/>
               </a:rPr>
               <a:t>并行策略自动寻优将人工调优周期从 2 周压缩至 8 小时, 叠加算子融合与通信掩盖优化, MFU 从 38% 提升至 52%。断点续训实现秒级恢复, 有效训练率稳定在 97%; 图算融合编译进一步带来长序列吞吐 35% 的提升, 显存分级复用使单卡可训参数量翻 2.4 倍, 训练效率整体达成 3 倍提升目标。</a:t>
             </a:r>
@@ -4458,7 +4598,14 @@
           <a:bodyPr rtlCol="0" anchor="ctr"/>
           <a:lstStyle/>
           <a:p>
-            <a:pPr algn="ctr"/>
+            <a:pPr algn="ctr">
+              <a:spcBef>
+                <a:spcPts val="0"/>
+              </a:spcBef>
+              <a:spcAft>
+                <a:spcPts val="0"/>
+              </a:spcAft>
+            </a:pPr>
           </a:p>
         </p:txBody>
       </p:sp>
@@ -4488,14 +4635,21 @@
               <a:lnSpc>
                 <a:spcPct val="112000"/>
               </a:lnSpc>
+              <a:spcBef>
+                <a:spcPts val="0"/>
+              </a:spcBef>
+              <a:spcAft>
+                <a:spcPts val="0"/>
+              </a:spcAft>
             </a:pPr>
             <a:r>
-              <a:rPr sz="1300" b="1" i="0">
+              <a:rPr sz="1300" b="1" i="0" lang="zh-CN" altLang="zh-CN">
                 <a:solidFill>
                   <a:srgbClr val="262626"/>
                 </a:solidFill>
                 <a:latin typeface="Microsoft YaHei"/>
                 <a:ea typeface="Microsoft YaHei"/>
+                <a:cs typeface="Microsoft YaHei"/>
               </a:rPr>
               <a:t>MFU 38%→52%</a:t>
             </a:r>
@@ -4528,14 +4682,21 @@
               <a:lnSpc>
                 <a:spcPct val="112000"/>
               </a:lnSpc>
+              <a:spcBef>
+                <a:spcPts val="0"/>
+              </a:spcBef>
+              <a:spcAft>
+                <a:spcPts val="0"/>
+              </a:spcAft>
             </a:pPr>
             <a:r>
-              <a:rPr sz="1000" b="1" i="0">
+              <a:rPr sz="1000" b="1" i="0" lang="zh-CN" altLang="zh-CN">
                 <a:solidFill>
                   <a:srgbClr val="595959"/>
                 </a:solidFill>
                 <a:latin typeface="Microsoft YaHei"/>
                 <a:ea typeface="Microsoft YaHei"/>
+                <a:cs typeface="Microsoft YaHei"/>
               </a:rPr>
               <a:t>训练效率提升 (相对基线)</a:t>
             </a:r>
@@ -4618,7 +4779,14 @@
           <a:bodyPr rtlCol="0" anchor="ctr"/>
           <a:lstStyle/>
           <a:p>
-            <a:pPr algn="ctr"/>
+            <a:pPr algn="ctr">
+              <a:spcBef>
+                <a:spcPts val="0"/>
+              </a:spcBef>
+              <a:spcAft>
+                <a:spcPts val="0"/>
+              </a:spcAft>
+            </a:pPr>
           </a:p>
         </p:txBody>
       </p:sp>
@@ -4630,8 +4798,8 @@
         </p:nvSpPr>
         <p:spPr>
           <a:xfrm>
-            <a:off x="9697508" y="2423160"/>
-            <a:ext cx="656166" cy="139700"/>
+            <a:off x="9697508" y="2402776"/>
+            <a:ext cx="656166" cy="180467"/>
           </a:xfrm>
           <a:prstGeom prst="rect">
             <a:avLst/>
@@ -4648,14 +4816,21 @@
               <a:lnSpc>
                 <a:spcPct val="112000"/>
               </a:lnSpc>
+              <a:spcBef>
+                <a:spcPts val="0"/>
+              </a:spcBef>
+              <a:spcAft>
+                <a:spcPts val="0"/>
+              </a:spcAft>
             </a:pPr>
             <a:r>
-              <a:rPr sz="1000" b="1" i="0">
+              <a:rPr sz="1000" b="1" i="0" lang="zh-CN" altLang="zh-CN">
                 <a:solidFill>
                   <a:srgbClr val="262626"/>
                 </a:solidFill>
                 <a:latin typeface="Microsoft YaHei"/>
                 <a:ea typeface="Microsoft YaHei"/>
+                <a:cs typeface="Microsoft YaHei"/>
               </a:rPr>
               <a:t>1.0x</a:t>
             </a:r>
@@ -4688,14 +4863,21 @@
               <a:lnSpc>
                 <a:spcPct val="112000"/>
               </a:lnSpc>
+              <a:spcBef>
+                <a:spcPts val="0"/>
+              </a:spcBef>
+              <a:spcAft>
+                <a:spcPts val="0"/>
+              </a:spcAft>
             </a:pPr>
             <a:r>
-              <a:rPr sz="950" b="0" i="0">
+              <a:rPr sz="950" b="0" i="0" lang="zh-CN" altLang="zh-CN">
                 <a:solidFill>
                   <a:srgbClr val="595959"/>
                 </a:solidFill>
                 <a:latin typeface="Microsoft YaHei"/>
                 <a:ea typeface="Microsoft YaHei"/>
+                <a:cs typeface="Microsoft YaHei"/>
               </a:rPr>
               <a:t>基线</a:t>
             </a:r>
@@ -4742,7 +4924,14 @@
           <a:bodyPr rtlCol="0" anchor="ctr"/>
           <a:lstStyle/>
           <a:p>
-            <a:pPr algn="ctr"/>
+            <a:pPr algn="ctr">
+              <a:spcBef>
+                <a:spcPts val="0"/>
+              </a:spcBef>
+              <a:spcAft>
+                <a:spcPts val="0"/>
+              </a:spcAft>
+            </a:pPr>
           </a:p>
         </p:txBody>
       </p:sp>
@@ -4754,8 +4943,8 @@
         </p:nvSpPr>
         <p:spPr>
           <a:xfrm>
-            <a:off x="10353675" y="1931415"/>
-            <a:ext cx="656166" cy="139700"/>
+            <a:off x="10353675" y="1911031"/>
+            <a:ext cx="656166" cy="180467"/>
           </a:xfrm>
           <a:prstGeom prst="rect">
             <a:avLst/>
@@ -4772,14 +4961,21 @@
               <a:lnSpc>
                 <a:spcPct val="112000"/>
               </a:lnSpc>
+              <a:spcBef>
+                <a:spcPts val="0"/>
+              </a:spcBef>
+              <a:spcAft>
+                <a:spcPts val="0"/>
+              </a:spcAft>
             </a:pPr>
             <a:r>
-              <a:rPr sz="1000" b="1" i="0">
+              <a:rPr sz="1000" b="1" i="0" lang="zh-CN" altLang="zh-CN">
                 <a:solidFill>
                   <a:srgbClr val="262626"/>
                 </a:solidFill>
                 <a:latin typeface="Microsoft YaHei"/>
                 <a:ea typeface="Microsoft YaHei"/>
+                <a:cs typeface="Microsoft YaHei"/>
               </a:rPr>
               <a:t>2.1x</a:t>
             </a:r>
@@ -4812,14 +5008,21 @@
               <a:lnSpc>
                 <a:spcPct val="112000"/>
               </a:lnSpc>
+              <a:spcBef>
+                <a:spcPts val="0"/>
+              </a:spcBef>
+              <a:spcAft>
+                <a:spcPts val="0"/>
+              </a:spcAft>
             </a:pPr>
             <a:r>
-              <a:rPr sz="950" b="0" i="0">
+              <a:rPr sz="950" b="0" i="0" lang="zh-CN" altLang="zh-CN">
                 <a:solidFill>
                   <a:srgbClr val="595959"/>
                 </a:solidFill>
                 <a:latin typeface="Microsoft YaHei"/>
                 <a:ea typeface="Microsoft YaHei"/>
+                <a:cs typeface="Microsoft YaHei"/>
               </a:rPr>
               <a:t>优化</a:t>
             </a:r>
@@ -4866,7 +5069,14 @@
           <a:bodyPr rtlCol="0" anchor="ctr"/>
           <a:lstStyle/>
           <a:p>
-            <a:pPr algn="ctr"/>
+            <a:pPr algn="ctr">
+              <a:spcBef>
+                <a:spcPts val="0"/>
+              </a:spcBef>
+              <a:spcAft>
+                <a:spcPts val="0"/>
+              </a:spcAft>
+            </a:pPr>
           </a:p>
         </p:txBody>
       </p:sp>
@@ -4878,8 +5088,8 @@
         </p:nvSpPr>
         <p:spPr>
           <a:xfrm>
-            <a:off x="11009841" y="1529080"/>
-            <a:ext cx="656166" cy="139700"/>
+            <a:off x="11009841" y="1508696"/>
+            <a:ext cx="656166" cy="180467"/>
           </a:xfrm>
           <a:prstGeom prst="rect">
             <a:avLst/>
@@ -4896,14 +5106,21 @@
               <a:lnSpc>
                 <a:spcPct val="112000"/>
               </a:lnSpc>
+              <a:spcBef>
+                <a:spcPts val="0"/>
+              </a:spcBef>
+              <a:spcAft>
+                <a:spcPts val="0"/>
+              </a:spcAft>
             </a:pPr>
             <a:r>
-              <a:rPr sz="1000" b="1" i="0">
+              <a:rPr sz="1000" b="1" i="0" lang="zh-CN" altLang="zh-CN">
                 <a:solidFill>
                   <a:srgbClr val="262626"/>
                 </a:solidFill>
                 <a:latin typeface="Microsoft YaHei"/>
                 <a:ea typeface="Microsoft YaHei"/>
+                <a:cs typeface="Microsoft YaHei"/>
               </a:rPr>
               <a:t>3.0x</a:t>
             </a:r>
@@ -4936,14 +5153,21 @@
               <a:lnSpc>
                 <a:spcPct val="112000"/>
               </a:lnSpc>
+              <a:spcBef>
+                <a:spcPts val="0"/>
+              </a:spcBef>
+              <a:spcAft>
+                <a:spcPts val="0"/>
+              </a:spcAft>
             </a:pPr>
             <a:r>
-              <a:rPr sz="950" b="0" i="0">
+              <a:rPr sz="950" b="0" i="0" lang="zh-CN" altLang="zh-CN">
                 <a:solidFill>
                   <a:srgbClr val="595959"/>
                 </a:solidFill>
                 <a:latin typeface="Microsoft YaHei"/>
                 <a:ea typeface="Microsoft YaHei"/>
+                <a:cs typeface="Microsoft YaHei"/>
               </a:rPr>
               <a:t>目标</a:t>
             </a:r>
@@ -4992,7 +5216,14 @@
           <a:bodyPr rtlCol="0" anchor="ctr"/>
           <a:lstStyle/>
           <a:p>
-            <a:pPr algn="ctr"/>
+            <a:pPr algn="ctr">
+              <a:spcBef>
+                <a:spcPts val="0"/>
+              </a:spcBef>
+              <a:spcAft>
+                <a:spcPts val="0"/>
+              </a:spcAft>
+            </a:pPr>
           </a:p>
         </p:txBody>
       </p:sp>
@@ -5036,7 +5267,14 @@
           <a:bodyPr rtlCol="0" anchor="ctr"/>
           <a:lstStyle/>
           <a:p>
-            <a:pPr algn="ctr"/>
+            <a:pPr algn="ctr">
+              <a:spcBef>
+                <a:spcPts val="0"/>
+              </a:spcBef>
+              <a:spcAft>
+                <a:spcPts val="0"/>
+              </a:spcAft>
+            </a:pPr>
           </a:p>
         </p:txBody>
       </p:sp>
@@ -5080,7 +5318,14 @@
           <a:bodyPr rtlCol="0" anchor="ctr"/>
           <a:lstStyle/>
           <a:p>
-            <a:pPr algn="ctr"/>
+            <a:pPr algn="ctr">
+              <a:spcBef>
+                <a:spcPts val="0"/>
+              </a:spcBef>
+              <a:spcAft>
+                <a:spcPts val="0"/>
+              </a:spcAft>
+            </a:pPr>
           </a:p>
         </p:txBody>
       </p:sp>
@@ -5110,14 +5355,21 @@
               <a:lnSpc>
                 <a:spcPct val="112000"/>
               </a:lnSpc>
+              <a:spcBef>
+                <a:spcPts val="0"/>
+              </a:spcBef>
+              <a:spcAft>
+                <a:spcPts val="0"/>
+              </a:spcAft>
             </a:pPr>
             <a:r>
-              <a:rPr sz="1500" b="1" i="0">
+              <a:rPr sz="1500" b="1" i="0" lang="zh-CN" altLang="zh-CN">
                 <a:solidFill>
                   <a:srgbClr val="262626"/>
                 </a:solidFill>
                 <a:latin typeface="Microsoft YaHei"/>
                 <a:ea typeface="Microsoft YaHei"/>
+                <a:cs typeface="Microsoft YaHei"/>
               </a:rPr>
               <a:t>集群互联: 灵衢总线统一互联协议</a:t>
             </a:r>
@@ -5150,14 +5402,21 @@
               <a:lnSpc>
                 <a:spcPct val="130000"/>
               </a:lnSpc>
+              <a:spcBef>
+                <a:spcPts val="0"/>
+              </a:spcBef>
+              <a:spcAft>
+                <a:spcPts val="0"/>
+              </a:spcAft>
             </a:pPr>
             <a:r>
-              <a:rPr sz="1150" b="0" i="0">
+              <a:rPr sz="1150" b="0" i="0" lang="zh-CN" altLang="zh-CN">
                 <a:solidFill>
                   <a:srgbClr val="262626"/>
                 </a:solidFill>
                 <a:latin typeface="Microsoft YaHei"/>
                 <a:ea typeface="Microsoft YaHei"/>
+                <a:cs typeface="Microsoft YaHei"/>
               </a:rPr>
               <a:t>UB 灵衢总线提供 392GB/s 互联带宽, 达 RoCE 主流方案的 15 倍, 配合全光交换 OXC 组网, 万卡集群布线复杂度直降 70%。拓扑感知的集合通信路由使 AllReduce 通信耗时下降 43%, 网络与计算联合调度让大消息通信与计算重叠率达到 85%; 链路亚健康秒级检测与隔离能力保障闪断业务零感知自动切换, 集群链路可用性提升至 99.99%, 中断次数月均不足 1 次, 为万卡规模训练提供稳定高速且持续可用的互联底座。</a:t>
             </a:r>
@@ -5204,7 +5463,14 @@
           <a:bodyPr rtlCol="0" anchor="ctr"/>
           <a:lstStyle/>
           <a:p>
-            <a:pPr algn="ctr"/>
+            <a:pPr algn="ctr">
+              <a:spcBef>
+                <a:spcPts val="0"/>
+              </a:spcBef>
+              <a:spcAft>
+                <a:spcPts val="0"/>
+              </a:spcAft>
+            </a:pPr>
           </a:p>
         </p:txBody>
       </p:sp>
@@ -5248,7 +5514,14 @@
           <a:bodyPr rtlCol="0" anchor="ctr"/>
           <a:lstStyle/>
           <a:p>
-            <a:pPr algn="ctr"/>
+            <a:pPr algn="ctr">
+              <a:spcBef>
+                <a:spcPts val="0"/>
+              </a:spcBef>
+              <a:spcAft>
+                <a:spcPts val="0"/>
+              </a:spcAft>
+            </a:pPr>
           </a:p>
         </p:txBody>
       </p:sp>
@@ -5292,7 +5565,14 @@
           <a:bodyPr rtlCol="0" anchor="ctr"/>
           <a:lstStyle/>
           <a:p>
-            <a:pPr algn="ctr"/>
+            <a:pPr algn="ctr">
+              <a:spcBef>
+                <a:spcPts val="0"/>
+              </a:spcBef>
+              <a:spcAft>
+                <a:spcPts val="0"/>
+              </a:spcAft>
+            </a:pPr>
           </a:p>
         </p:txBody>
       </p:sp>
@@ -5430,14 +5710,21 @@
               <a:lnSpc>
                 <a:spcPct val="112000"/>
               </a:lnSpc>
+              <a:spcBef>
+                <a:spcPts val="0"/>
+              </a:spcBef>
+              <a:spcAft>
+                <a:spcPts val="0"/>
+              </a:spcAft>
             </a:pPr>
             <a:r>
-              <a:rPr sz="950" b="0" i="0">
+              <a:rPr sz="950" b="0" i="0" lang="zh-CN" altLang="zh-CN">
                 <a:solidFill>
                   <a:srgbClr val="595959"/>
                 </a:solidFill>
                 <a:latin typeface="Microsoft YaHei"/>
                 <a:ea typeface="Microsoft YaHei"/>
+                <a:cs typeface="Microsoft YaHei"/>
               </a:rPr>
               <a:t>UB-Mesh 全互联</a:t>
             </a:r>
@@ -5484,7 +5771,14 @@
           <a:bodyPr rtlCol="0" anchor="ctr"/>
           <a:lstStyle/>
           <a:p>
-            <a:pPr algn="ctr"/>
+            <a:pPr algn="ctr">
+              <a:spcBef>
+                <a:spcPts val="0"/>
+              </a:spcBef>
+              <a:spcAft>
+                <a:spcPts val="0"/>
+              </a:spcAft>
+            </a:pPr>
           </a:p>
         </p:txBody>
       </p:sp>
@@ -5514,14 +5808,21 @@
               <a:lnSpc>
                 <a:spcPct val="112000"/>
               </a:lnSpc>
+              <a:spcBef>
+                <a:spcPts val="0"/>
+              </a:spcBef>
+              <a:spcAft>
+                <a:spcPts val="0"/>
+              </a:spcAft>
             </a:pPr>
             <a:r>
-              <a:rPr sz="1300" b="1" i="0">
+              <a:rPr sz="1300" b="1" i="0" lang="zh-CN" altLang="zh-CN">
                 <a:solidFill>
                   <a:srgbClr val="262626"/>
                 </a:solidFill>
                 <a:latin typeface="Microsoft YaHei"/>
                 <a:ea typeface="Microsoft YaHei"/>
+                <a:cs typeface="Microsoft YaHei"/>
               </a:rPr>
               <a:t>带宽 392GB/s</a:t>
             </a:r>
@@ -5568,7 +5869,14 @@
           <a:bodyPr rtlCol="0" anchor="ctr"/>
           <a:lstStyle/>
           <a:p>
-            <a:pPr algn="ctr"/>
+            <a:pPr algn="ctr">
+              <a:spcBef>
+                <a:spcPts val="0"/>
+              </a:spcBef>
+              <a:spcAft>
+                <a:spcPts val="0"/>
+              </a:spcAft>
+            </a:pPr>
           </a:p>
         </p:txBody>
       </p:sp>
@@ -5598,14 +5906,21 @@
               <a:lnSpc>
                 <a:spcPct val="112000"/>
               </a:lnSpc>
+              <a:spcBef>
+                <a:spcPts val="0"/>
+              </a:spcBef>
+              <a:spcAft>
+                <a:spcPts val="0"/>
+              </a:spcAft>
             </a:pPr>
             <a:r>
-              <a:rPr sz="1300" b="1" i="0">
+              <a:rPr sz="1300" b="1" i="0" lang="zh-CN" altLang="zh-CN">
                 <a:solidFill>
                   <a:srgbClr val="262626"/>
                 </a:solidFill>
                 <a:latin typeface="Microsoft YaHei"/>
                 <a:ea typeface="Microsoft YaHei"/>
+                <a:cs typeface="Microsoft YaHei"/>
               </a:rPr>
               <a:t>通信耗时 -43%</a:t>
             </a:r>
@@ -5654,7 +5969,14 @@
           <a:bodyPr rtlCol="0" anchor="ctr"/>
           <a:lstStyle/>
           <a:p>
-            <a:pPr algn="ctr"/>
+            <a:pPr algn="ctr">
+              <a:spcBef>
+                <a:spcPts val="0"/>
+              </a:spcBef>
+              <a:spcAft>
+                <a:spcPts val="0"/>
+              </a:spcAft>
+            </a:pPr>
           </a:p>
         </p:txBody>
       </p:sp>
@@ -5698,7 +6020,14 @@
           <a:bodyPr rtlCol="0" anchor="ctr"/>
           <a:lstStyle/>
           <a:p>
-            <a:pPr algn="ctr"/>
+            <a:pPr algn="ctr">
+              <a:spcBef>
+                <a:spcPts val="0"/>
+              </a:spcBef>
+              <a:spcAft>
+                <a:spcPts val="0"/>
+              </a:spcAft>
+            </a:pPr>
           </a:p>
         </p:txBody>
       </p:sp>
@@ -5742,7 +6071,14 @@
           <a:bodyPr rtlCol="0" anchor="ctr"/>
           <a:lstStyle/>
           <a:p>
-            <a:pPr algn="ctr"/>
+            <a:pPr algn="ctr">
+              <a:spcBef>
+                <a:spcPts val="0"/>
+              </a:spcBef>
+              <a:spcAft>
+                <a:spcPts val="0"/>
+              </a:spcAft>
+            </a:pPr>
           </a:p>
         </p:txBody>
       </p:sp>
@@ -5772,14 +6108,21 @@
               <a:lnSpc>
                 <a:spcPct val="112000"/>
               </a:lnSpc>
+              <a:spcBef>
+                <a:spcPts val="0"/>
+              </a:spcBef>
+              <a:spcAft>
+                <a:spcPts val="0"/>
+              </a:spcAft>
             </a:pPr>
             <a:r>
-              <a:rPr sz="1500" b="1" i="0">
+              <a:rPr sz="1500" b="1" i="0" lang="zh-CN" altLang="zh-CN">
                 <a:solidFill>
                   <a:srgbClr val="262626"/>
                 </a:solidFill>
                 <a:latin typeface="Microsoft YaHei"/>
                 <a:ea typeface="Microsoft YaHei"/>
+                <a:cs typeface="Microsoft YaHei"/>
               </a:rPr>
               <a:t>稳定可靠: 训练中断率持续收敛</a:t>
             </a:r>
@@ -5812,14 +6155,21 @@
               <a:lnSpc>
                 <a:spcPct val="130000"/>
               </a:lnSpc>
+              <a:spcBef>
+                <a:spcPts val="0"/>
+              </a:spcBef>
+              <a:spcAft>
+                <a:spcPts val="0"/>
+              </a:spcAft>
             </a:pPr>
             <a:r>
-              <a:rPr sz="1150" b="0" i="0">
+              <a:rPr sz="1150" b="0" i="0" lang="zh-CN" altLang="zh-CN">
                 <a:solidFill>
                   <a:srgbClr val="262626"/>
                 </a:solidFill>
                 <a:latin typeface="Microsoft YaHei"/>
                 <a:ea typeface="Microsoft YaHei"/>
+                <a:cs typeface="Microsoft YaHei"/>
               </a:rPr>
               <a:t>全栈可观测体系打通芯片、框架与任务三层指标, 故障预测可提前 30 分钟预警且准确率达 91%。慢节点支持在线热替换, 任务无感迁移小于 60 秒; 光模块故障自愈使闪断恢复秒级完成, 亚健康节点自动隔离的误隔离率低于 0.5%, Checkpoint 异步多级备份将回滚时间控制在 5 分钟以内, 已实现千卡连续训练 30 天无人工干预。</a:t>
             </a:r>
@@ -5852,14 +6202,21 @@
               <a:lnSpc>
                 <a:spcPct val="112000"/>
               </a:lnSpc>
+              <a:spcBef>
+                <a:spcPts val="0"/>
+              </a:spcBef>
+              <a:spcAft>
+                <a:spcPts val="0"/>
+              </a:spcAft>
             </a:pPr>
             <a:r>
-              <a:rPr sz="1000" b="1" i="0">
+              <a:rPr sz="1000" b="1" i="0" lang="zh-CN" altLang="zh-CN">
                 <a:solidFill>
                   <a:srgbClr val="595959"/>
                 </a:solidFill>
                 <a:latin typeface="Microsoft YaHei"/>
                 <a:ea typeface="Microsoft YaHei"/>
+                <a:cs typeface="Microsoft YaHei"/>
               </a:rPr>
               <a:t>千卡任务月均中断次数</a:t>
             </a:r>
@@ -6122,7 +6479,14 @@
           <a:bodyPr rtlCol="0" anchor="ctr"/>
           <a:lstStyle/>
           <a:p>
-            <a:pPr algn="ctr"/>
+            <a:pPr algn="ctr">
+              <a:spcBef>
+                <a:spcPts val="0"/>
+              </a:spcBef>
+              <a:spcAft>
+                <a:spcPts val="0"/>
+              </a:spcAft>
+            </a:pPr>
           </a:p>
         </p:txBody>
       </p:sp>
@@ -6134,8 +6498,8 @@
         </p:nvSpPr>
         <p:spPr>
           <a:xfrm>
-            <a:off x="9702800" y="4306276"/>
-            <a:ext cx="304800" cy="127000"/>
+            <a:off x="9702800" y="4283479"/>
+            <a:ext cx="304800" cy="172593"/>
           </a:xfrm>
           <a:prstGeom prst="rect">
             <a:avLst/>
@@ -6152,14 +6516,21 @@
               <a:lnSpc>
                 <a:spcPct val="112000"/>
               </a:lnSpc>
+              <a:spcBef>
+                <a:spcPts val="0"/>
+              </a:spcBef>
+              <a:spcAft>
+                <a:spcPts val="0"/>
+              </a:spcAft>
             </a:pPr>
             <a:r>
-              <a:rPr sz="950" b="0" i="0">
+              <a:rPr sz="950" b="0" i="0" lang="zh-CN" altLang="zh-CN">
                 <a:solidFill>
                   <a:srgbClr val="262626"/>
                 </a:solidFill>
                 <a:latin typeface="Microsoft YaHei"/>
                 <a:ea typeface="Microsoft YaHei"/>
+                <a:cs typeface="Microsoft YaHei"/>
               </a:rPr>
               <a:t>12</a:t>
             </a:r>
@@ -6174,8 +6545,8 @@
         </p:nvSpPr>
         <p:spPr>
           <a:xfrm>
-            <a:off x="9664700" y="5511800"/>
-            <a:ext cx="381000" cy="139700"/>
+            <a:off x="9664700" y="5495353"/>
+            <a:ext cx="381000" cy="172593"/>
           </a:xfrm>
           <a:prstGeom prst="rect">
             <a:avLst/>
@@ -6192,14 +6563,21 @@
               <a:lnSpc>
                 <a:spcPct val="112000"/>
               </a:lnSpc>
+              <a:spcBef>
+                <a:spcPts val="0"/>
+              </a:spcBef>
+              <a:spcAft>
+                <a:spcPts val="0"/>
+              </a:spcAft>
             </a:pPr>
             <a:r>
-              <a:rPr sz="950" b="0" i="0">
+              <a:rPr sz="950" b="0" i="0" lang="zh-CN" altLang="zh-CN">
                 <a:solidFill>
                   <a:srgbClr val="595959"/>
                 </a:solidFill>
                 <a:latin typeface="Microsoft YaHei"/>
                 <a:ea typeface="Microsoft YaHei"/>
+                <a:cs typeface="Microsoft YaHei"/>
               </a:rPr>
               <a:t>24H2</a:t>
             </a:r>
@@ -6246,7 +6624,14 @@
           <a:bodyPr rtlCol="0" anchor="ctr"/>
           <a:lstStyle/>
           <a:p>
-            <a:pPr algn="ctr"/>
+            <a:pPr algn="ctr">
+              <a:spcBef>
+                <a:spcPts val="0"/>
+              </a:spcBef>
+              <a:spcAft>
+                <a:spcPts val="0"/>
+              </a:spcAft>
+            </a:pPr>
           </a:p>
         </p:txBody>
       </p:sp>
@@ -6258,8 +6643,8 @@
         </p:nvSpPr>
         <p:spPr>
           <a:xfrm>
-            <a:off x="10112375" y="4631917"/>
-            <a:ext cx="304800" cy="127000"/>
+            <a:off x="10112375" y="4609120"/>
+            <a:ext cx="304800" cy="172593"/>
           </a:xfrm>
           <a:prstGeom prst="rect">
             <a:avLst/>
@@ -6276,14 +6661,21 @@
               <a:lnSpc>
                 <a:spcPct val="112000"/>
               </a:lnSpc>
+              <a:spcBef>
+                <a:spcPts val="0"/>
+              </a:spcBef>
+              <a:spcAft>
+                <a:spcPts val="0"/>
+              </a:spcAft>
             </a:pPr>
             <a:r>
-              <a:rPr sz="950" b="0" i="0">
+              <a:rPr sz="950" b="0" i="0" lang="zh-CN" altLang="zh-CN">
                 <a:solidFill>
                   <a:srgbClr val="262626"/>
                 </a:solidFill>
                 <a:latin typeface="Microsoft YaHei"/>
                 <a:ea typeface="Microsoft YaHei"/>
+                <a:cs typeface="Microsoft YaHei"/>
               </a:rPr>
               <a:t>8</a:t>
             </a:r>
@@ -6298,8 +6690,8 @@
         </p:nvSpPr>
         <p:spPr>
           <a:xfrm>
-            <a:off x="10074275" y="5511800"/>
-            <a:ext cx="381000" cy="139700"/>
+            <a:off x="10074275" y="5495353"/>
+            <a:ext cx="381000" cy="172593"/>
           </a:xfrm>
           <a:prstGeom prst="rect">
             <a:avLst/>
@@ -6316,14 +6708,21 @@
               <a:lnSpc>
                 <a:spcPct val="112000"/>
               </a:lnSpc>
+              <a:spcBef>
+                <a:spcPts val="0"/>
+              </a:spcBef>
+              <a:spcAft>
+                <a:spcPts val="0"/>
+              </a:spcAft>
             </a:pPr>
             <a:r>
-              <a:rPr sz="950" b="0" i="0">
+              <a:rPr sz="950" b="0" i="0" lang="zh-CN" altLang="zh-CN">
                 <a:solidFill>
                   <a:srgbClr val="595959"/>
                 </a:solidFill>
                 <a:latin typeface="Microsoft YaHei"/>
                 <a:ea typeface="Microsoft YaHei"/>
+                <a:cs typeface="Microsoft YaHei"/>
               </a:rPr>
               <a:t>25Q1</a:t>
             </a:r>
@@ -6370,7 +6769,14 @@
           <a:bodyPr rtlCol="0" anchor="ctr"/>
           <a:lstStyle/>
           <a:p>
-            <a:pPr algn="ctr"/>
+            <a:pPr algn="ctr">
+              <a:spcBef>
+                <a:spcPts val="0"/>
+              </a:spcBef>
+              <a:spcAft>
+                <a:spcPts val="0"/>
+              </a:spcAft>
+            </a:pPr>
           </a:p>
         </p:txBody>
       </p:sp>
@@ -6382,8 +6788,8 @@
         </p:nvSpPr>
         <p:spPr>
           <a:xfrm>
-            <a:off x="10521950" y="4876148"/>
-            <a:ext cx="304800" cy="127000"/>
+            <a:off x="10521950" y="4853351"/>
+            <a:ext cx="304800" cy="172593"/>
           </a:xfrm>
           <a:prstGeom prst="rect">
             <a:avLst/>
@@ -6400,14 +6806,21 @@
               <a:lnSpc>
                 <a:spcPct val="112000"/>
               </a:lnSpc>
+              <a:spcBef>
+                <a:spcPts val="0"/>
+              </a:spcBef>
+              <a:spcAft>
+                <a:spcPts val="0"/>
+              </a:spcAft>
             </a:pPr>
             <a:r>
-              <a:rPr sz="950" b="0" i="0">
+              <a:rPr sz="950" b="0" i="0" lang="zh-CN" altLang="zh-CN">
                 <a:solidFill>
                   <a:srgbClr val="262626"/>
                 </a:solidFill>
                 <a:latin typeface="Microsoft YaHei"/>
                 <a:ea typeface="Microsoft YaHei"/>
+                <a:cs typeface="Microsoft YaHei"/>
               </a:rPr>
               <a:t>5</a:t>
             </a:r>
@@ -6422,8 +6835,8 @@
         </p:nvSpPr>
         <p:spPr>
           <a:xfrm>
-            <a:off x="10483850" y="5511800"/>
-            <a:ext cx="381000" cy="139700"/>
+            <a:off x="10483850" y="5495353"/>
+            <a:ext cx="381000" cy="172593"/>
           </a:xfrm>
           <a:prstGeom prst="rect">
             <a:avLst/>
@@ -6440,14 +6853,21 @@
               <a:lnSpc>
                 <a:spcPct val="112000"/>
               </a:lnSpc>
+              <a:spcBef>
+                <a:spcPts val="0"/>
+              </a:spcBef>
+              <a:spcAft>
+                <a:spcPts val="0"/>
+              </a:spcAft>
             </a:pPr>
             <a:r>
-              <a:rPr sz="950" b="0" i="0">
+              <a:rPr sz="950" b="0" i="0" lang="zh-CN" altLang="zh-CN">
                 <a:solidFill>
                   <a:srgbClr val="595959"/>
                 </a:solidFill>
                 <a:latin typeface="Microsoft YaHei"/>
                 <a:ea typeface="Microsoft YaHei"/>
+                <a:cs typeface="Microsoft YaHei"/>
               </a:rPr>
               <a:t>25Q2</a:t>
             </a:r>
@@ -6494,7 +6914,14 @@
           <a:bodyPr rtlCol="0" anchor="ctr"/>
           <a:lstStyle/>
           <a:p>
-            <a:pPr algn="ctr"/>
+            <a:pPr algn="ctr">
+              <a:spcBef>
+                <a:spcPts val="0"/>
+              </a:spcBef>
+              <a:spcAft>
+                <a:spcPts val="0"/>
+              </a:spcAft>
+            </a:pPr>
           </a:p>
         </p:txBody>
       </p:sp>
@@ -6506,8 +6933,8 @@
         </p:nvSpPr>
         <p:spPr>
           <a:xfrm>
-            <a:off x="10931525" y="5038969"/>
-            <a:ext cx="304800" cy="127000"/>
+            <a:off x="10931525" y="5016172"/>
+            <a:ext cx="304800" cy="172593"/>
           </a:xfrm>
           <a:prstGeom prst="rect">
             <a:avLst/>
@@ -6524,14 +6951,21 @@
               <a:lnSpc>
                 <a:spcPct val="112000"/>
               </a:lnSpc>
+              <a:spcBef>
+                <a:spcPts val="0"/>
+              </a:spcBef>
+              <a:spcAft>
+                <a:spcPts val="0"/>
+              </a:spcAft>
             </a:pPr>
             <a:r>
-              <a:rPr sz="950" b="0" i="0">
+              <a:rPr sz="950" b="0" i="0" lang="zh-CN" altLang="zh-CN">
                 <a:solidFill>
                   <a:srgbClr val="262626"/>
                 </a:solidFill>
                 <a:latin typeface="Microsoft YaHei"/>
                 <a:ea typeface="Microsoft YaHei"/>
+                <a:cs typeface="Microsoft YaHei"/>
               </a:rPr>
               <a:t>3</a:t>
             </a:r>
@@ -6546,8 +6980,8 @@
         </p:nvSpPr>
         <p:spPr>
           <a:xfrm>
-            <a:off x="10893425" y="5511800"/>
-            <a:ext cx="381000" cy="139700"/>
+            <a:off x="10893425" y="5495353"/>
+            <a:ext cx="381000" cy="172593"/>
           </a:xfrm>
           <a:prstGeom prst="rect">
             <a:avLst/>
@@ -6564,14 +6998,21 @@
               <a:lnSpc>
                 <a:spcPct val="112000"/>
               </a:lnSpc>
+              <a:spcBef>
+                <a:spcPts val="0"/>
+              </a:spcBef>
+              <a:spcAft>
+                <a:spcPts val="0"/>
+              </a:spcAft>
             </a:pPr>
             <a:r>
-              <a:rPr sz="950" b="0" i="0">
+              <a:rPr sz="950" b="0" i="0" lang="zh-CN" altLang="zh-CN">
                 <a:solidFill>
                   <a:srgbClr val="595959"/>
                 </a:solidFill>
                 <a:latin typeface="Microsoft YaHei"/>
                 <a:ea typeface="Microsoft YaHei"/>
+                <a:cs typeface="Microsoft YaHei"/>
               </a:rPr>
               <a:t>25Q3</a:t>
             </a:r>
@@ -6618,7 +7059,14 @@
           <a:bodyPr rtlCol="0" anchor="ctr"/>
           <a:lstStyle/>
           <a:p>
-            <a:pPr algn="ctr"/>
+            <a:pPr algn="ctr">
+              <a:spcBef>
+                <a:spcPts val="0"/>
+              </a:spcBef>
+              <a:spcAft>
+                <a:spcPts val="0"/>
+              </a:spcAft>
+            </a:pPr>
           </a:p>
         </p:txBody>
       </p:sp>
@@ -6630,8 +7078,8 @@
         </p:nvSpPr>
         <p:spPr>
           <a:xfrm>
-            <a:off x="11341100" y="5201789"/>
-            <a:ext cx="304800" cy="127000"/>
+            <a:off x="11341100" y="5178992"/>
+            <a:ext cx="304800" cy="172593"/>
           </a:xfrm>
           <a:prstGeom prst="rect">
             <a:avLst/>
@@ -6648,14 +7096,21 @@
               <a:lnSpc>
                 <a:spcPct val="112000"/>
               </a:lnSpc>
+              <a:spcBef>
+                <a:spcPts val="0"/>
+              </a:spcBef>
+              <a:spcAft>
+                <a:spcPts val="0"/>
+              </a:spcAft>
             </a:pPr>
             <a:r>
-              <a:rPr sz="950" b="0" i="0">
+              <a:rPr sz="950" b="0" i="0" lang="zh-CN" altLang="zh-CN">
                 <a:solidFill>
                   <a:srgbClr val="262626"/>
                 </a:solidFill>
                 <a:latin typeface="Microsoft YaHei"/>
                 <a:ea typeface="Microsoft YaHei"/>
+                <a:cs typeface="Microsoft YaHei"/>
               </a:rPr>
               <a:t>1</a:t>
             </a:r>
@@ -6670,8 +7125,8 @@
         </p:nvSpPr>
         <p:spPr>
           <a:xfrm>
-            <a:off x="11303000" y="5511800"/>
-            <a:ext cx="381000" cy="139700"/>
+            <a:off x="11303000" y="5495353"/>
+            <a:ext cx="381000" cy="172593"/>
           </a:xfrm>
           <a:prstGeom prst="rect">
             <a:avLst/>
@@ -6688,14 +7143,21 @@
               <a:lnSpc>
                 <a:spcPct val="112000"/>
               </a:lnSpc>
+              <a:spcBef>
+                <a:spcPts val="0"/>
+              </a:spcBef>
+              <a:spcAft>
+                <a:spcPts val="0"/>
+              </a:spcAft>
             </a:pPr>
             <a:r>
-              <a:rPr sz="950" b="0" i="0">
+              <a:rPr sz="950" b="0" i="0" lang="zh-CN" altLang="zh-CN">
                 <a:solidFill>
                   <a:srgbClr val="595959"/>
                 </a:solidFill>
                 <a:latin typeface="Microsoft YaHei"/>
                 <a:ea typeface="Microsoft YaHei"/>
+                <a:cs typeface="Microsoft YaHei"/>
               </a:rPr>
               <a:t>25Q4</a:t>
             </a:r>
@@ -6742,7 +7204,14 @@
           <a:bodyPr rtlCol="0" anchor="ctr"/>
           <a:lstStyle/>
           <a:p>
-            <a:pPr algn="ctr"/>
+            <a:pPr algn="ctr">
+              <a:spcBef>
+                <a:spcPts val="0"/>
+              </a:spcBef>
+              <a:spcAft>
+                <a:spcPts val="0"/>
+              </a:spcAft>
+            </a:pPr>
           </a:p>
         </p:txBody>
       </p:sp>
@@ -6772,14 +7241,21 @@
               <a:lnSpc>
                 <a:spcPct val="112000"/>
               </a:lnSpc>
+              <a:spcBef>
+                <a:spcPts val="0"/>
+              </a:spcBef>
+              <a:spcAft>
+                <a:spcPts val="0"/>
+              </a:spcAft>
             </a:pPr>
             <a:r>
-              <a:rPr sz="1300" b="1" i="0">
+              <a:rPr sz="1300" b="1" i="0" lang="zh-CN" altLang="zh-CN">
                 <a:solidFill>
                   <a:srgbClr val="262626"/>
                 </a:solidFill>
                 <a:latin typeface="Microsoft YaHei"/>
                 <a:ea typeface="Microsoft YaHei"/>
+                <a:cs typeface="Microsoft YaHei"/>
               </a:rPr>
               <a:t>有效训练率 97%</a:t>
             </a:r>

</xml_diff>